<commit_message>
Reframe SWOT as Cisco View about Altera
Update the India one-pager and Account Plan SWOT to reflect how Cisco
evaluates Altera (strengths, gaps, attach opportunities, and competitor threats).

Co-authored-by: rushikeshpurohit0908 <rushikeshpurohit0908@users.noreply.github.com>
</commit_message>
<xml_diff>
--- a/presentations/Cisco_India_Collaboration_OnePager.pptx
+++ b/presentations/Cisco_India_Collaboration_OnePager.pptx
@@ -4837,7 +4837,7 @@
                 <a:ea typeface="Liberation Sans"/>
                 <a:cs typeface="Liberation Sans"/>
               </a:rPr>
-              <a:t>SWOT Analysis — Customer View (Cisco India)</a:t>
+              <a:t>SWOT Analysis — Cisco View about Altera</a:t>
             </a:r>
           </a:p>
         </p:txBody>
@@ -5005,7 +5005,7 @@
                 <a:ea typeface="Liberation Sans"/>
                 <a:cs typeface="Liberation Sans"/>
               </a:rPr>
-              <a:t>30+ FPGA eng in Bengaluru; owns SP routing &amp; optical design</a:t>
+              <a:t>Agilex fabric power/perf; strong IP &amp; turnkey / P4 architectures</a:t>
             </a:r>
           </a:p>
           <a:p>
@@ -5025,7 +5025,7 @@
                 <a:ea typeface="Liberation Sans"/>
                 <a:cs typeface="Liberation Sans"/>
               </a:rPr>
-              <a:t>8000 / ASR platforms + Silicon One datapath leadership</a:t>
+              <a:t>AI/ML Tensor blocks; A5/A3 fit for control-plane &amp; BMC</a:t>
             </a:r>
           </a:p>
           <a:p>
@@ -5045,7 +5045,7 @@
                 <a:ea typeface="Liberation Sans"/>
                 <a:cs typeface="Liberation Sans"/>
               </a:rPr>
-              <a:t>Deep director bench (Alap, Akhil, Vijay)</a:t>
+              <a:t>Local Bengaluru FAE depth (TM timing, MCDMA, APS)</a:t>
             </a:r>
           </a:p>
         </p:txBody>
@@ -5213,7 +5213,7 @@
                 <a:ea typeface="Liberation Sans"/>
                 <a:cs typeface="Liberation Sans"/>
               </a:rPr>
-              <a:t>Control plane locked to Xilinx Artix / Microchip SF2</a:t>
+              <a:t>Uncompetitive &lt;$20 / no ~$8 secure device vs PolarFire</a:t>
             </a:r>
           </a:p>
           <a:p>
@@ -5233,7 +5233,7 @@
                 <a:ea typeface="Liberation Sans"/>
                 <a:cs typeface="Liberation Sans"/>
               </a:rPr>
-              <a:t>Slow FPGA vendor switch; price-sensitive RFQs</a:t>
+              <a:t>Agilex 5 ~40% above Lattice on India RFQs; A3 cost high</a:t>
             </a:r>
           </a:p>
           <a:p>
@@ -5253,7 +5253,7 @@
                 <a:ea typeface="Liberation Sans"/>
                 <a:cs typeface="Liberation Sans"/>
               </a:rPr>
-              <a:t>Legacy codebases raise migration cost</a:t>
+              <a:t>No DDR5 on Agilex 7; memory ratio / crypto HIP gaps vs AMD</a:t>
             </a:r>
           </a:p>
         </p:txBody>
@@ -5421,7 +5421,7 @@
                 <a:ea typeface="Liberation Sans"/>
                 <a:cs typeface="Liberation Sans"/>
               </a:rPr>
-              <a:t>Control-plane refresh; PQC / secure-boot mandates</a:t>
+              <a:t>Displace Artix / SF2 on control plane with A5 + PQC secure boot</a:t>
             </a:r>
           </a:p>
           <a:p>
@@ -5441,7 +5441,7 @@
                 <a:ea typeface="Liberation Sans"/>
                 <a:cs typeface="Liberation Sans"/>
               </a:rPr>
-              <a:t>Make-in-India manufacturing expands local programs</a:t>
+              <a:t>TM / Lavena Agilex 7 wins; MAX10 BMC &amp; platform attach</a:t>
             </a:r>
           </a:p>
           <a:p>
@@ -5461,7 +5461,7 @@
                 <a:ea typeface="Liberation Sans"/>
                 <a:cs typeface="Liberation Sans"/>
               </a:rPr>
-              <a:t>AI/ML on control path &amp; BMC attach</a:t>
+              <a:t>AI telemetry / ASSP-ASIC replacement sockets in India designs</a:t>
             </a:r>
           </a:p>
         </p:txBody>
@@ -5629,7 +5629,7 @@
                 <a:ea typeface="Liberation Sans"/>
                 <a:cs typeface="Liberation Sans"/>
               </a:rPr>
-              <a:t>ASIC absorption of datapath value</a:t>
+              <a:t>AMD Versal 2 HIP / HBM3; Lattice mid-range with HP XCVRs</a:t>
             </a:r>
           </a:p>
           <a:p>
@@ -5649,7 +5649,7 @@
                 <a:ea typeface="Liberation Sans"/>
                 <a:cs typeface="Liberation Sans"/>
               </a:rPr>
-              <a:t>Lattice / AMD / PolarFire price-feature pressure</a:t>
+              <a:t>PolarFire security lock-in; virtualization cuts FPGA content</a:t>
             </a:r>
           </a:p>
           <a:p>
@@ -5669,7 +5669,7 @@
                 <a:ea typeface="Liberation Sans"/>
                 <a:cs typeface="Liberation Sans"/>
               </a:rPr>
-              <a:t>Virtualization &amp; SW disrupts HW attach</a:t>
+              <a:t>Geopolitics / indigenous FPGA pressure; LPDDR4 EOL cycle</a:t>
             </a:r>
           </a:p>
         </p:txBody>

</xml_diff>